<commit_message>
Apply new proposed training schedule dates across course data, lesson plans, and decks
</commit_message>
<xml_diff>
--- a/public/downloads/US-114051-L1-Knowledge-of-Meetings.pptx
+++ b/public/downloads/US-114051-L1-Knowledge-of-Meetings.pptx
@@ -2455,7 +2455,7 @@
                 <a:ea typeface="Aptos" pitchFamily="34" charset="-122"/>
                 <a:cs typeface="Aptos" pitchFamily="34" charset="-120"/>
               </a:rPr>
-              <a:t>What meetings are for, the types organisations hold, leadership styles, decision-making processes, resolutions and the conventions that keep meetings fair</a:t>
+              <a:t>What meetings are for, the types companies hold, leadership styles, decision-making processes, resolutions and the conventions that keep meetings fair</a:t>
             </a:r>
             <a:endParaRPr lang="en-US" sz="1900" dirty="0"/>
           </a:p>
@@ -2670,7 +2670,7 @@
                 <a:ea typeface="Aptos" pitchFamily="34" charset="-122"/>
                 <a:cs typeface="Aptos" pitchFamily="34" charset="-120"/>
               </a:rPr>
-              <a:t>Friday, 4 Sep 2026 · 09h00 – 14h00</a:t>
+              <a:t>Thursday, 3 Sep 2026 · 09h00 – 14h00</a:t>
             </a:r>
             <a:endParaRPr lang="en-US" sz="1800" dirty="0"/>
           </a:p>
@@ -5332,7 +5332,7 @@
                 <a:ea typeface="Aptos" pitchFamily="34" charset="-122"/>
                 <a:cs typeface="Aptos" pitchFamily="34" charset="-120"/>
               </a:rPr>
-              <a:t>A proposal is usually put forward by one person, seconded by another, and then voted on — if the majority accept it, it becomes binding on the organisation.</a:t>
+              <a:t>A proposal is usually put forward by one person, seconded by another, and then voted on — if the majority accept it, it becomes binding on the company.</a:t>
             </a:r>
             <a:endParaRPr lang="en-US" sz="1800" dirty="0"/>
           </a:p>
@@ -5634,7 +5634,7 @@
                 <a:ea typeface="Aptos" pitchFamily="34" charset="-122"/>
                 <a:cs typeface="Aptos" pitchFamily="34" charset="-120"/>
               </a:rPr>
-              <a:t>Resolutions are formal proposals put to the meeting to agree or disagree with; if passed they become policy of the organisation. Each needs a proposer and a seconder.</a:t>
+              <a:t>Resolutions are formal proposals put to the meeting to agree or disagree with; if passed they become policy of the company. Each needs a proposer and a seconder.</a:t>
             </a:r>
             <a:endParaRPr lang="en-US" sz="1800" dirty="0"/>
           </a:p>
@@ -5706,7 +5706,7 @@
                 <a:ea typeface="Aptos" pitchFamily="34" charset="-122"/>
                 <a:cs typeface="Aptos" pitchFamily="34" charset="-120"/>
               </a:rPr>
-              <a:t>THEREFORE RESOLVES — list exactly what the organisation has decided to do or what its policy is on the issue.</a:t>
+              <a:t>THEREFORE RESOLVES — list exactly what the company has decided to do or what its policy is on the issue.</a:t>
             </a:r>
             <a:endParaRPr lang="en-US" sz="1800" dirty="0"/>
           </a:p>
@@ -10142,7 +10142,7 @@
                 <a:ea typeface="Aptos" pitchFamily="34" charset="-122"/>
                 <a:cs typeface="Aptos" pitchFamily="34" charset="-120"/>
               </a:rPr>
-              <a:t>Meetings are very important for the work of any organisation — good meetings support collective decision-making, planning and follow-up, accountability and democracy.</a:t>
+              <a:t>Meetings are very important for the work of any company — good meetings support collective decision-making, planning and follow-up, accountability and democracy.</a:t>
             </a:r>
             <a:endParaRPr lang="en-US" sz="1800" dirty="0"/>
           </a:p>
@@ -10166,7 +10166,7 @@
                 <a:ea typeface="Aptos" pitchFamily="34" charset="-122"/>
                 <a:cs typeface="Aptos" pitchFamily="34" charset="-120"/>
               </a:rPr>
-              <a:t>Used correctly, meetings help an organisation to be efficient. Used badly, they stop serving their purpose: too many long meetings that discuss the same thing over and over without moving forward.</a:t>
+              <a:t>Used correctly, meetings help a company to be efficient. Used badly, they stop serving their purpose: too many long meetings that discuss the same thing over and over without moving forward.</a:t>
             </a:r>
             <a:endParaRPr lang="en-US" sz="1800" dirty="0"/>
           </a:p>
@@ -10190,7 +10190,7 @@
                 <a:ea typeface="Aptos" pitchFamily="34" charset="-122"/>
                 <a:cs typeface="Aptos" pitchFamily="34" charset="-120"/>
               </a:rPr>
-              <a:t>Meetings can become places where conflict is played out — and some people see attending meetings as working for the organisation, instead of a tool for getting work done.</a:t>
+              <a:t>Meetings can become places where conflict is played out — and some people see attending meetings as working for the company, instead of a tool for getting work done.</a:t>
             </a:r>
             <a:endParaRPr lang="en-US" sz="1800" dirty="0"/>
           </a:p>
@@ -10238,7 +10238,7 @@
                 <a:ea typeface="Aptos" pitchFamily="34" charset="-122"/>
                 <a:cs typeface="Aptos" pitchFamily="34" charset="-120"/>
               </a:rPr>
-              <a:t>The principal activities of a technical committee are the development and maintenance of its standards, technical reports and data files, in accordance with the purpose of the organisation.</a:t>
+              <a:t>The principal activities of a technical committee are the development and maintenance of its standards, technical reports and data files, in accordance with the purpose of the company.</a:t>
             </a:r>
             <a:endParaRPr lang="en-US" sz="1800" dirty="0"/>
           </a:p>
@@ -10540,7 +10540,7 @@
                 <a:ea typeface="Aptos" pitchFamily="34" charset="-122"/>
                 <a:cs typeface="Aptos" pitchFamily="34" charset="-120"/>
               </a:rPr>
-              <a:t>Decide on the different types of meetings needed: some meetings discuss policy, others discuss organisation (practical work).</a:t>
+              <a:t>Decide on the different types of meetings needed: some meetings discuss policy, others discuss practical work.</a:t>
             </a:r>
             <a:endParaRPr lang="en-US" sz="1800" dirty="0"/>
           </a:p>
@@ -10588,7 +10588,7 @@
                 <a:ea typeface="Aptos" pitchFamily="34" charset="-122"/>
                 <a:cs typeface="Aptos" pitchFamily="34" charset="-120"/>
               </a:rPr>
-              <a:t>Sometimes an organisation calls a special or extraordinary meeting — planning should take account of the meeting type.</a:t>
+              <a:t>Sometimes a company calls a special or extraordinary meeting — planning should take account of the meeting type.</a:t>
             </a:r>
             <a:endParaRPr lang="en-US" sz="1800" dirty="0"/>
           </a:p>
@@ -10796,7 +10796,7 @@
                 <a:ea typeface="Aptos Display" pitchFamily="34" charset="-122"/>
                 <a:cs typeface="Aptos Display" pitchFamily="34" charset="-120"/>
               </a:rPr>
-              <a:t>The meetings most organisations hold</a:t>
+              <a:t>The meetings most companies hold</a:t>
             </a:r>
             <a:endParaRPr lang="en-US" sz="3000" dirty="0"/>
           </a:p>
@@ -11715,7 +11715,7 @@
                 <a:ea typeface="Aptos" pitchFamily="34" charset="-122"/>
                 <a:cs typeface="Aptos" pitchFamily="34" charset="-120"/>
               </a:rPr>
-              <a:t>The plans of the organisation for the year</a:t>
+              <a:t>The plans of the company for the year</a:t>
             </a:r>
             <a:endParaRPr lang="en-US" sz="1800" dirty="0"/>
           </a:p>
@@ -14133,7 +14133,7 @@
                 <a:ea typeface="Aptos" pitchFamily="34" charset="-122"/>
                 <a:cs typeface="Aptos" pitchFamily="34" charset="-120"/>
               </a:rPr>
-              <a:t>Held with appointed or nominated delegates from departments, organisations or areas. Delegates are given the information and all members have a voice in decision-making.</a:t>
+              <a:t>Held with appointed or nominated delegates from departments, companies or areas. Delegates are given the information and all members have a voice in decision-making.</a:t>
             </a:r>
             <a:endParaRPr lang="en-US" sz="1800" dirty="0"/>
           </a:p>

</xml_diff>